<commit_message>
Add a checked Sources and go deeper block to every room and download.
Each room keeps a sources.json. Papers, specs, vendor docs, community pages, and Wikipedia fallbacks are linked with last checked 2026-10. Pages that did not open are marked confirm.

Co-authored-by: CYPHER0X9 <cipher0x9@users.noreply.github.com>
</commit_message>
<xml_diff>
--- a/downloads/ai-omni-lab-deck.pptx
+++ b/downloads/ai-omni-lab-deck.pptx
@@ -3259,6 +3259,101 @@
               <a:t>Tests and a small eval</a:t>
             </a:r>
           </a:p>
+          <a:p>
+            <a:r>
+              <a:t>Sources and go deeper</a:t>
+            </a:r>
+          </a:p>
+          <a:p>
+            <a:r>
+              <a:t>NIST AI Risk Management Framework (spec)</a:t>
+            </a:r>
+          </a:p>
+          <a:p>
+            <a:r>
+              <a:t>last checked 2026-10</a:t>
+            </a:r>
+          </a:p>
+          <a:p>
+            <a:r>
+              <a:t>https://www.nist.gov/itl/ai-risk-management-framework</a:t>
+            </a:r>
+          </a:p>
+          <a:p>
+            <a:r>
+              <a:t>W3C, Web Content Accessibility Guidelines 2.2 (spec)</a:t>
+            </a:r>
+          </a:p>
+          <a:p>
+            <a:r>
+              <a:t>last checked 2026-10</a:t>
+            </a:r>
+          </a:p>
+          <a:p>
+            <a:r>
+              <a:t>https://www.w3.org/TR/WCAG22/</a:t>
+            </a:r>
+          </a:p>
+          <a:p>
+            <a:r>
+              <a:t>Web accessibility — Wikipedia (wikipedia)</a:t>
+            </a:r>
+          </a:p>
+          <a:p>
+            <a:r>
+              <a:t>last checked 2026-10</a:t>
+            </a:r>
+          </a:p>
+          <a:p>
+            <a:r>
+              <a:t>https://en.wikipedia.org/wiki/Web_accessibility</a:t>
+            </a:r>
+          </a:p>
+          <a:p>
+            <a:r>
+              <a:t>Python 3 tutorial (vendor)</a:t>
+            </a:r>
+          </a:p>
+          <a:p>
+            <a:r>
+              <a:t>last checked 2026-10</a:t>
+            </a:r>
+          </a:p>
+          <a:p>
+            <a:r>
+              <a:t>https://docs.python.org/3/tutorial/</a:t>
+            </a:r>
+          </a:p>
+          <a:p>
+            <a:r>
+              <a:t>Python.org community (community)</a:t>
+            </a:r>
+          </a:p>
+          <a:p>
+            <a:r>
+              <a:t>last checked 2026-10</a:t>
+            </a:r>
+          </a:p>
+          <a:p>
+            <a:r>
+              <a:t>https://www.python.org/community/</a:t>
+            </a:r>
+          </a:p>
+          <a:p>
+            <a:r>
+              <a:t>Git reference (vendor)</a:t>
+            </a:r>
+          </a:p>
+          <a:p>
+            <a:r>
+              <a:t>last checked 2026-10</a:t>
+            </a:r>
+          </a:p>
+          <a:p>
+            <a:r>
+              <a:t>https://git-scm.com/docs</a:t>
+            </a:r>
+          </a:p>
         </p:txBody>
       </p:sp>
       <p:sp>
@@ -3396,6 +3491,101 @@
               <a:t>Model cards and ids</a:t>
             </a:r>
           </a:p>
+          <a:p>
+            <a:r>
+              <a:t>Sources and go deeper</a:t>
+            </a:r>
+          </a:p>
+          <a:p>
+            <a:r>
+              <a:t>Vaswani and co-authors, Attention Is All You Need, 2017 (paper)</a:t>
+            </a:r>
+          </a:p>
+          <a:p>
+            <a:r>
+              <a:t>last checked 2026-10</a:t>
+            </a:r>
+          </a:p>
+          <a:p>
+            <a:r>
+              <a:t>https://arxiv.org/abs/1706.03762</a:t>
+            </a:r>
+          </a:p>
+          <a:p>
+            <a:r>
+              <a:t>Brown and co-authors, Language Models are Few-Shot Learners, 2020 (paper)</a:t>
+            </a:r>
+          </a:p>
+          <a:p>
+            <a:r>
+              <a:t>last checked 2026-10</a:t>
+            </a:r>
+          </a:p>
+          <a:p>
+            <a:r>
+              <a:t>https://arxiv.org/abs/2005.14165</a:t>
+            </a:r>
+          </a:p>
+          <a:p>
+            <a:r>
+              <a:t>Attention Is All You Need — Wikipedia (wikipedia)</a:t>
+            </a:r>
+          </a:p>
+          <a:p>
+            <a:r>
+              <a:t>last checked 2026-10</a:t>
+            </a:r>
+          </a:p>
+          <a:p>
+            <a:r>
+              <a:t>https://en.wikipedia.org/wiki/Attention_Is_All_You_Need</a:t>
+            </a:r>
+          </a:p>
+          <a:p>
+            <a:r>
+              <a:t>Large language model — Wikipedia (wikipedia)</a:t>
+            </a:r>
+          </a:p>
+          <a:p>
+            <a:r>
+              <a:t>last checked 2026-10</a:t>
+            </a:r>
+          </a:p>
+          <a:p>
+            <a:r>
+              <a:t>https://en.wikipedia.org/wiki/Large_language_model</a:t>
+            </a:r>
+          </a:p>
+          <a:p>
+            <a:r>
+              <a:t>NIST AI Risk Management Framework (spec)</a:t>
+            </a:r>
+          </a:p>
+          <a:p>
+            <a:r>
+              <a:t>last checked 2026-10</a:t>
+            </a:r>
+          </a:p>
+          <a:p>
+            <a:r>
+              <a:t>https://www.nist.gov/itl/ai-risk-management-framework</a:t>
+            </a:r>
+          </a:p>
+          <a:p>
+            <a:r>
+              <a:t>OWASP Top 10 for Large Language Model Applications (community)</a:t>
+            </a:r>
+          </a:p>
+          <a:p>
+            <a:r>
+              <a:t>last checked 2026-10</a:t>
+            </a:r>
+          </a:p>
+          <a:p>
+            <a:r>
+              <a:t>https://owasp.org/projects/top-10-for-large-language-model-applications</a:t>
+            </a:r>
+          </a:p>
         </p:txBody>
       </p:sp>
       <p:sp>
@@ -3533,6 +3723,101 @@
               <a:t>Prompt diff</a:t>
             </a:r>
           </a:p>
+          <a:p>
+            <a:r>
+              <a:t>Sources and go deeper</a:t>
+            </a:r>
+          </a:p>
+          <a:p>
+            <a:r>
+              <a:t>Brown and co-authors, Language Models are Few-Shot Learners, 2020 (paper)</a:t>
+            </a:r>
+          </a:p>
+          <a:p>
+            <a:r>
+              <a:t>last checked 2026-10</a:t>
+            </a:r>
+          </a:p>
+          <a:p>
+            <a:r>
+              <a:t>https://arxiv.org/abs/2005.14165</a:t>
+            </a:r>
+          </a:p>
+          <a:p>
+            <a:r>
+              <a:t>Prompt engineering — Wikipedia (wikipedia)</a:t>
+            </a:r>
+          </a:p>
+          <a:p>
+            <a:r>
+              <a:t>last checked 2026-10</a:t>
+            </a:r>
+          </a:p>
+          <a:p>
+            <a:r>
+              <a:t>https://en.wikipedia.org/wiki/Prompt_engineering</a:t>
+            </a:r>
+          </a:p>
+          <a:p>
+            <a:r>
+              <a:t>Anthropic, Building effective agents (vendor)</a:t>
+            </a:r>
+          </a:p>
+          <a:p>
+            <a:r>
+              <a:t>last checked 2026-10</a:t>
+            </a:r>
+          </a:p>
+          <a:p>
+            <a:r>
+              <a:t>https://www.anthropic.com/engineering/building-effective-agents</a:t>
+            </a:r>
+          </a:p>
+          <a:p>
+            <a:r>
+              <a:t>Amazon Bedrock overview (vendor)</a:t>
+            </a:r>
+          </a:p>
+          <a:p>
+            <a:r>
+              <a:t>last checked 2026-10</a:t>
+            </a:r>
+          </a:p>
+          <a:p>
+            <a:r>
+              <a:t>https://docs.aws.amazon.com/bedrock/latest/userguide/what-is-bedrock.html</a:t>
+            </a:r>
+          </a:p>
+          <a:p>
+            <a:r>
+              <a:t>RFC 8259, The JSON Data Interchange Format (spec)</a:t>
+            </a:r>
+          </a:p>
+          <a:p>
+            <a:r>
+              <a:t>last checked 2026-10</a:t>
+            </a:r>
+          </a:p>
+          <a:p>
+            <a:r>
+              <a:t>https://www.rfc-editor.org/rfc/rfc8259</a:t>
+            </a:r>
+          </a:p>
+          <a:p>
+            <a:r>
+              <a:t>OWASP Top 10 for Large Language Model Applications (community)</a:t>
+            </a:r>
+          </a:p>
+          <a:p>
+            <a:r>
+              <a:t>last checked 2026-10</a:t>
+            </a:r>
+          </a:p>
+          <a:p>
+            <a:r>
+              <a:t>https://owasp.org/projects/top-10-for-large-language-model-applications</a:t>
+            </a:r>
+          </a:p>
         </p:txBody>
       </p:sp>
       <p:sp>
@@ -3670,6 +3955,86 @@
               <a:t>Failure modes</a:t>
             </a:r>
           </a:p>
+          <a:p>
+            <a:r>
+              <a:t>Sources and go deeper</a:t>
+            </a:r>
+          </a:p>
+          <a:p>
+            <a:r>
+              <a:t>Lewis and co-authors, Retrieval-Augmented Generation for Knowledge-Intensive NLP Tasks, 2020 (paper)</a:t>
+            </a:r>
+          </a:p>
+          <a:p>
+            <a:r>
+              <a:t>last checked 2026-10</a:t>
+            </a:r>
+          </a:p>
+          <a:p>
+            <a:r>
+              <a:t>https://arxiv.org/abs/2005.11401</a:t>
+            </a:r>
+          </a:p>
+          <a:p>
+            <a:r>
+              <a:t>Retrieval-augmented generation — Wikipedia (wikipedia)</a:t>
+            </a:r>
+          </a:p>
+          <a:p>
+            <a:r>
+              <a:t>last checked 2026-10</a:t>
+            </a:r>
+          </a:p>
+          <a:p>
+            <a:r>
+              <a:t>https://en.wikipedia.org/wiki/Retrieval-augmented_generation</a:t>
+            </a:r>
+          </a:p>
+          <a:p>
+            <a:r>
+              <a:t>Karpukhin and co-authors, Dense Passage Retrieval for Open-Domain Question Answering, 2020 (paper)</a:t>
+            </a:r>
+          </a:p>
+          <a:p>
+            <a:r>
+              <a:t>last checked 2026-10</a:t>
+            </a:r>
+          </a:p>
+          <a:p>
+            <a:r>
+              <a:t>https://arxiv.org/abs/2004.04906</a:t>
+            </a:r>
+          </a:p>
+          <a:p>
+            <a:r>
+              <a:t>Word embedding — Wikipedia (wikipedia)</a:t>
+            </a:r>
+          </a:p>
+          <a:p>
+            <a:r>
+              <a:t>last checked 2026-10</a:t>
+            </a:r>
+          </a:p>
+          <a:p>
+            <a:r>
+              <a:t>https://en.wikipedia.org/wiki/Word_embedding</a:t>
+            </a:r>
+          </a:p>
+          <a:p>
+            <a:r>
+              <a:t>OWASP Top 10 for Large Language Model Applications (community)</a:t>
+            </a:r>
+          </a:p>
+          <a:p>
+            <a:r>
+              <a:t>last checked 2026-10</a:t>
+            </a:r>
+          </a:p>
+          <a:p>
+            <a:r>
+              <a:t>https://owasp.org/projects/top-10-for-large-language-model-applications</a:t>
+            </a:r>
+          </a:p>
         </p:txBody>
       </p:sp>
       <p:sp>
@@ -3807,6 +4172,101 @@
               <a:t>When not to use an agent</a:t>
             </a:r>
           </a:p>
+          <a:p>
+            <a:r>
+              <a:t>Sources and go deeper</a:t>
+            </a:r>
+          </a:p>
+          <a:p>
+            <a:r>
+              <a:t>Anthropic, Building effective agents (vendor)</a:t>
+            </a:r>
+          </a:p>
+          <a:p>
+            <a:r>
+              <a:t>last checked 2026-10</a:t>
+            </a:r>
+          </a:p>
+          <a:p>
+            <a:r>
+              <a:t>https://www.anthropic.com/engineering/building-effective-agents</a:t>
+            </a:r>
+          </a:p>
+          <a:p>
+            <a:r>
+              <a:t>Yao and co-authors, ReAct: Synergizing Reasoning and Acting in Language Models, 2022 (paper)</a:t>
+            </a:r>
+          </a:p>
+          <a:p>
+            <a:r>
+              <a:t>last checked 2026-10</a:t>
+            </a:r>
+          </a:p>
+          <a:p>
+            <a:r>
+              <a:t>https://arxiv.org/abs/2210.03629</a:t>
+            </a:r>
+          </a:p>
+          <a:p>
+            <a:r>
+              <a:t>Large language model — Wikipedia (wikipedia)</a:t>
+            </a:r>
+          </a:p>
+          <a:p>
+            <a:r>
+              <a:t>last checked 2026-10</a:t>
+            </a:r>
+          </a:p>
+          <a:p>
+            <a:r>
+              <a:t>https://en.wikipedia.org/wiki/Large_language_model</a:t>
+            </a:r>
+          </a:p>
+          <a:p>
+            <a:r>
+              <a:t>Schick and co-authors, Toolformer: Language Models Can Teach Themselves to Use Tools, 2023 (paper)</a:t>
+            </a:r>
+          </a:p>
+          <a:p>
+            <a:r>
+              <a:t>last checked 2026-10</a:t>
+            </a:r>
+          </a:p>
+          <a:p>
+            <a:r>
+              <a:t>https://arxiv.org/abs/2302.04761</a:t>
+            </a:r>
+          </a:p>
+          <a:p>
+            <a:r>
+              <a:t>NIST AI Risk Management Framework (spec)</a:t>
+            </a:r>
+          </a:p>
+          <a:p>
+            <a:r>
+              <a:t>last checked 2026-10</a:t>
+            </a:r>
+          </a:p>
+          <a:p>
+            <a:r>
+              <a:t>https://www.nist.gov/itl/ai-risk-management-framework</a:t>
+            </a:r>
+          </a:p>
+          <a:p>
+            <a:r>
+              <a:t>OWASP Top 10 for Large Language Model Applications (community)</a:t>
+            </a:r>
+          </a:p>
+          <a:p>
+            <a:r>
+              <a:t>last checked 2026-10</a:t>
+            </a:r>
+          </a:p>
+          <a:p>
+            <a:r>
+              <a:t>https://owasp.org/projects/top-10-for-large-language-model-applications</a:t>
+            </a:r>
+          </a:p>
         </p:txBody>
       </p:sp>
       <p:sp>
@@ -3944,6 +4404,101 @@
               <a:t>A notes server on paper</a:t>
             </a:r>
           </a:p>
+          <a:p>
+            <a:r>
+              <a:t>Sources and go deeper</a:t>
+            </a:r>
+          </a:p>
+          <a:p>
+            <a:r>
+              <a:t>Model Context Protocol specification, 2025-06-18 (spec)</a:t>
+            </a:r>
+          </a:p>
+          <a:p>
+            <a:r>
+              <a:t>last checked 2026-10</a:t>
+            </a:r>
+          </a:p>
+          <a:p>
+            <a:r>
+              <a:t>https://modelcontextprotocol.io/specification/2025-06-18</a:t>
+            </a:r>
+          </a:p>
+          <a:p>
+            <a:r>
+              <a:t>What is the Model Context Protocol (MCP)? (spec)</a:t>
+            </a:r>
+          </a:p>
+          <a:p>
+            <a:r>
+              <a:t>last checked 2026-10</a:t>
+            </a:r>
+          </a:p>
+          <a:p>
+            <a:r>
+              <a:t>https://modelcontextprotocol.io/docs/2026-07-28/getting-started/intro</a:t>
+            </a:r>
+          </a:p>
+          <a:p>
+            <a:r>
+              <a:t>Model Context Protocol organization on GitHub (community)</a:t>
+            </a:r>
+          </a:p>
+          <a:p>
+            <a:r>
+              <a:t>last checked 2026-10</a:t>
+            </a:r>
+          </a:p>
+          <a:p>
+            <a:r>
+              <a:t>https://github.com/modelcontextprotocol</a:t>
+            </a:r>
+          </a:p>
+          <a:p>
+            <a:r>
+              <a:t>Model Context Protocol — Wikipedia (wikipedia)</a:t>
+            </a:r>
+          </a:p>
+          <a:p>
+            <a:r>
+              <a:t>last checked 2026-10</a:t>
+            </a:r>
+          </a:p>
+          <a:p>
+            <a:r>
+              <a:t>https://en.wikipedia.org/wiki/Model_Context_Protocol</a:t>
+            </a:r>
+          </a:p>
+          <a:p>
+            <a:r>
+              <a:t>RFC 9110, HTTP Semantics (spec)</a:t>
+            </a:r>
+          </a:p>
+          <a:p>
+            <a:r>
+              <a:t>last checked 2026-10</a:t>
+            </a:r>
+          </a:p>
+          <a:p>
+            <a:r>
+              <a:t>https://www.rfc-editor.org/rfc/rfc9110</a:t>
+            </a:r>
+          </a:p>
+          <a:p>
+            <a:r>
+              <a:t>HTTP — Wikipedia (wikipedia)</a:t>
+            </a:r>
+          </a:p>
+          <a:p>
+            <a:r>
+              <a:t>last checked 2026-10</a:t>
+            </a:r>
+          </a:p>
+          <a:p>
+            <a:r>
+              <a:t>https://en.wikipedia.org/wiki/HTTP</a:t>
+            </a:r>
+          </a:p>
         </p:txBody>
       </p:sp>
       <p:sp>
@@ -4081,6 +4636,106 @@
               <a:t>What this lab will not claim</a:t>
             </a:r>
           </a:p>
+          <a:p>
+            <a:r>
+              <a:t>Sources and go deeper</a:t>
+            </a:r>
+          </a:p>
+          <a:p>
+            <a:r>
+              <a:t>NIST AI Risk Management Framework (spec)</a:t>
+            </a:r>
+          </a:p>
+          <a:p>
+            <a:r>
+              <a:t>last checked 2026-10</a:t>
+            </a:r>
+          </a:p>
+          <a:p>
+            <a:r>
+              <a:t>https://www.nist.gov/itl/ai-risk-management-framework</a:t>
+            </a:r>
+          </a:p>
+          <a:p>
+            <a:r>
+              <a:t>Large language model — Wikipedia (wikipedia)</a:t>
+            </a:r>
+          </a:p>
+          <a:p>
+            <a:r>
+              <a:t>last checked 2026-10</a:t>
+            </a:r>
+          </a:p>
+          <a:p>
+            <a:r>
+              <a:t>https://en.wikipedia.org/wiki/Large_language_model</a:t>
+            </a:r>
+          </a:p>
+          <a:p>
+            <a:r>
+              <a:t>MDN Web Docs, Web Speech API (community)</a:t>
+            </a:r>
+          </a:p>
+          <a:p>
+            <a:r>
+              <a:t>last checked 2026-10</a:t>
+            </a:r>
+          </a:p>
+          <a:p>
+            <a:r>
+              <a:t>https://developer.mozilla.org/en-US/docs/Web/API/Web_Speech_API</a:t>
+            </a:r>
+          </a:p>
+          <a:p>
+            <a:r>
+              <a:t>Web Speech API community draft (community)</a:t>
+            </a:r>
+          </a:p>
+          <a:p>
+            <a:r>
+              <a:t>last checked 2026-10</a:t>
+            </a:r>
+          </a:p>
+          <a:p>
+            <a:r>
+              <a:t>https://webaudio.github.io/web-speech-api/</a:t>
+            </a:r>
+          </a:p>
+          <a:p>
+            <a:r>
+              <a:t>W3C /TR/speech-api/ (spec) confirm</a:t>
+            </a:r>
+          </a:p>
+          <a:p>
+            <a:r>
+              <a:t>This URL returned 404 on 2026-10. The community draft above is the page that opened.</a:t>
+            </a:r>
+          </a:p>
+          <a:p>
+            <a:r>
+              <a:t>last checked 2026-10</a:t>
+            </a:r>
+          </a:p>
+          <a:p>
+            <a:r>
+              <a:t>https://www.w3.org/TR/speech-api/</a:t>
+            </a:r>
+          </a:p>
+          <a:p>
+            <a:r>
+              <a:t>Speech synthesis — Wikipedia (wikipedia)</a:t>
+            </a:r>
+          </a:p>
+          <a:p>
+            <a:r>
+              <a:t>last checked 2026-10</a:t>
+            </a:r>
+          </a:p>
+          <a:p>
+            <a:r>
+              <a:t>https://en.wikipedia.org/wiki/Speech_synthesis</a:t>
+            </a:r>
+          </a:p>
         </p:txBody>
       </p:sp>
       <p:sp>
@@ -4216,6 +4871,111 @@
           <a:p>
             <a:r>
               <a:t>Capstone and certifications</a:t>
+            </a:r>
+          </a:p>
+          <a:p>
+            <a:r>
+              <a:t>Sources and go deeper</a:t>
+            </a:r>
+          </a:p>
+          <a:p>
+            <a:r>
+              <a:t>NVIDIA H100 GPU product page. Confirm any number before quoting it. (vendor)</a:t>
+            </a:r>
+          </a:p>
+          <a:p>
+            <a:r>
+              <a:t>last checked 2026-10</a:t>
+            </a:r>
+          </a:p>
+          <a:p>
+            <a:r>
+              <a:t>https://www.nvidia.com/en-us/data-center/h100/</a:t>
+            </a:r>
+          </a:p>
+          <a:p>
+            <a:r>
+              <a:t>Graphics processing unit — Wikipedia (wikipedia)</a:t>
+            </a:r>
+          </a:p>
+          <a:p>
+            <a:r>
+              <a:t>last checked 2026-10</a:t>
+            </a:r>
+          </a:p>
+          <a:p>
+            <a:r>
+              <a:t>https://en.wikipedia.org/wiki/Graphics_processing_unit</a:t>
+            </a:r>
+          </a:p>
+          <a:p>
+            <a:r>
+              <a:t>Hopper (microarchitecture) — Wikipedia (wikipedia)</a:t>
+            </a:r>
+          </a:p>
+          <a:p>
+            <a:r>
+              <a:t>The H100 title redirects to the Hopper page.</a:t>
+            </a:r>
+          </a:p>
+          <a:p>
+            <a:r>
+              <a:t>last checked 2026-10</a:t>
+            </a:r>
+          </a:p>
+          <a:p>
+            <a:r>
+              <a:t>https://en.wikipedia.org/wiki/Nvidia_H100</a:t>
+            </a:r>
+          </a:p>
+          <a:p>
+            <a:r>
+              <a:t>xAI public site (vendor) confirm</a:t>
+            </a:r>
+          </a:p>
+          <a:p>
+            <a:r>
+              <a:t>The site root returned 403 on 2026-10.</a:t>
+            </a:r>
+          </a:p>
+          <a:p>
+            <a:r>
+              <a:t>last checked 2026-10</a:t>
+            </a:r>
+          </a:p>
+          <a:p>
+            <a:r>
+              <a:t>https://x.ai/</a:t>
+            </a:r>
+          </a:p>
+          <a:p>
+            <a:r>
+              <a:t>Colossus: The World's Largest AI Supercomputer (vendor)</a:t>
+            </a:r>
+          </a:p>
+          <a:p>
+            <a:r>
+              <a:t>last checked 2026-10</a:t>
+            </a:r>
+          </a:p>
+          <a:p>
+            <a:r>
+              <a:t>https://x.ai/colossus</a:t>
+            </a:r>
+          </a:p>
+          <a:p>
+            <a:r>
+              <a:t>Amazon Bedrock overview (vendor)</a:t>
+            </a:r>
+          </a:p>
+          <a:p>
+            <a:r>
+              <a:t>last checked 2026-10</a:t>
+            </a:r>
+          </a:p>
+          <a:p>
+            <a:r>
+              <a:t>https://docs.aws.amazon.com/bedrock/latest/userguide/what-is-bedrock.html</a:t>
             </a:r>
           </a:p>
         </p:txBody>

</xml_diff>

<commit_message>
Show cited sources on every room, chapter, and download.
Opened pages stay linked and dated 2026-10. Pages that returned 403 or 404 are marked confirm with no URL. The home page now explains the lab with those sources, the tour card sits below the hero, and the floating bars and icons share one glow.

Co-authored-by: CYPHER0X9 <cipher0x9@users.noreply.github.com>
</commit_message>
<xml_diff>
--- a/downloads/ai-omni-lab-deck.pptx
+++ b/downloads/ai-omni-lab-deck.pptx
@@ -4718,11 +4718,6 @@
           </a:p>
           <a:p>
             <a:r>
-              <a:t>https://www.w3.org/TR/speech-api/</a:t>
-            </a:r>
-          </a:p>
-          <a:p>
-            <a:r>
               <a:t>Speech synthesis — Wikipedia (wikipedia)</a:t>
             </a:r>
           </a:p>
@@ -4945,22 +4940,17 @@
           </a:p>
           <a:p>
             <a:r>
-              <a:t>https://x.ai/</a:t>
-            </a:r>
-          </a:p>
-          <a:p>
-            <a:r>
-              <a:t>Colossus: The World's Largest AI Supercomputer (vendor)</a:t>
+              <a:t>Colossus supercomputer page on the xAI site (vendor) confirm</a:t>
+            </a:r>
+          </a:p>
+          <a:p>
+            <a:r>
+              <a:t>This URL returned 403 on 2026-10, so it is not linked.</a:t>
             </a:r>
           </a:p>
           <a:p>
             <a:r>
               <a:t>last checked 2026-10</a:t>
-            </a:r>
-          </a:p>
-          <a:p>
-            <a:r>
-              <a:t>https://x.ai/colossus</a:t>
             </a:r>
           </a:p>
           <a:p>

</xml_diff>

<commit_message>
Show cited sources on every room, chapter, and download. (#14)
Opened pages stay linked and dated 2026-10. Pages that returned 403 or 404 are marked confirm with no URL. The home page now explains the lab with those sources, the tour card sits below the hero, and the floating bars and icons share one glow.

Co-authored-by: Cursor Agent <cursoragent@cursor.com>
Co-authored-by: CYPHER0X9 <cipher0x9@users.noreply.github.com>
</commit_message>
<xml_diff>
--- a/downloads/ai-omni-lab-deck.pptx
+++ b/downloads/ai-omni-lab-deck.pptx
@@ -4718,11 +4718,6 @@
           </a:p>
           <a:p>
             <a:r>
-              <a:t>https://www.w3.org/TR/speech-api/</a:t>
-            </a:r>
-          </a:p>
-          <a:p>
-            <a:r>
               <a:t>Speech synthesis — Wikipedia (wikipedia)</a:t>
             </a:r>
           </a:p>
@@ -4945,22 +4940,17 @@
           </a:p>
           <a:p>
             <a:r>
-              <a:t>https://x.ai/</a:t>
-            </a:r>
-          </a:p>
-          <a:p>
-            <a:r>
-              <a:t>Colossus: The World's Largest AI Supercomputer (vendor)</a:t>
+              <a:t>Colossus supercomputer page on the xAI site (vendor) confirm</a:t>
+            </a:r>
+          </a:p>
+          <a:p>
+            <a:r>
+              <a:t>This URL returned 403 on 2026-10, so it is not linked.</a:t>
             </a:r>
           </a:p>
           <a:p>
             <a:r>
               <a:t>last checked 2026-10</a:t>
-            </a:r>
-          </a:p>
-          <a:p>
-            <a:r>
-              <a:t>https://x.ai/colossus</a:t>
             </a:r>
           </a:p>
           <a:p>

</xml_diff>

<commit_message>
Add voice, analytics, safety, and contact-center chapters.
The front door now has 12 tracks and 70 rooms. Each new chapter is in the menu, and every page and download still ends with sources opened in 2026-10.

Co-authored-by: CYPHER0X9 <cipher0x9@users.noreply.github.com>
</commit_message>
<xml_diff>
--- a/downloads/ai-omni-lab-deck.pptx
+++ b/downloads/ai-omni-lab-deck.pptx
@@ -14,6 +14,10 @@
     <p:sldId id="262" r:id="rId13"/>
     <p:sldId id="263" r:id="rId14"/>
     <p:sldId id="264" r:id="rId15"/>
+    <p:sldId id="265" r:id="rId16"/>
+    <p:sldId id="266" r:id="rId17"/>
+    <p:sldId id="267" r:id="rId18"/>
+    <p:sldId id="268" r:id="rId19"/>
   </p:sldIdLst>
   <p:sldSz cx="9144000" cy="6858000" type="screen4x3"/>
   <p:notesSz cx="6858000" cy="9144000"/>
@@ -3147,7 +3151,930 @@
           <a:lstStyle/>
           <a:p>
             <a:r>
-              <a:t>This is an independent, free, learning-only student project. It respects every company and vendor, and every trademark belongs to its owner. It is not affiliated with or endorsed by any of them. If anyone has a concern, the content will be removed or corrected promptly via the contact page. Nothing here is sold. The author is happy to volunteer.</a:t>
+              <a:t>This is an independent, free, learning-only student project. It respects every company and vendor, and every trademark belongs to its owner. It is not affiliated with or endorsed by any of them. If anyone has a concern, the content will be removed or corrected promptly via the contact page. Nothing here is sold. The author is happy to volunteer. Notes about recording, consent, and emergency calling are educational and are not legal advice.</a:t>
+            </a:r>
+          </a:p>
+        </p:txBody>
+      </p:sp>
+    </p:spTree>
+  </p:cSld>
+  <p:clrMapOvr>
+    <a:masterClrMapping/>
+  </p:clrMapOvr>
+</p:sld>
+</file>
+
+<file path=ppt/slides/slide10.xml><?xml version="1.0" encoding="utf-8"?>
+<p:sld xmlns:a="http://schemas.openxmlformats.org/drawingml/2006/main" xmlns:p="http://schemas.openxmlformats.org/presentationml/2006/main" xmlns:r="http://schemas.openxmlformats.org/officeDocument/2006/relationships">
+  <p:cSld>
+    <p:spTree>
+      <p:nvGrpSpPr>
+        <p:cNvPr id="1" name=""/>
+        <p:cNvGrpSpPr/>
+        <p:nvPr/>
+      </p:nvGrpSpPr>
+      <p:grpSpPr/>
+      <p:sp>
+        <p:nvSpPr>
+          <p:cNvPr id="2" name="TextBox 1"/>
+          <p:cNvSpPr txBox="1"/>
+          <p:nvPr/>
+        </p:nvSpPr>
+        <p:spPr>
+          <a:xfrm>
+            <a:off x="457200" y="365760"/>
+            <a:ext cx="8229600" cy="914400"/>
+          </a:xfrm>
+          <a:prstGeom prst="rect">
+            <a:avLst/>
+          </a:prstGeom>
+          <a:noFill/>
+        </p:spPr>
+        <p:txBody>
+          <a:bodyPr wrap="none">
+            <a:spAutoFit/>
+          </a:bodyPr>
+          <a:lstStyle/>
+          <a:p>
+            <a:r>
+              <a:rPr sz="3200">
+                <a:solidFill>
+                  <a:srgbClr val="0F172A"/>
+                </a:solidFill>
+              </a:rPr>
+              <a:t>Voice AI agent stack</a:t>
+            </a:r>
+          </a:p>
+        </p:txBody>
+      </p:sp>
+      <p:sp>
+        <p:nvSpPr>
+          <p:cNvPr id="3" name="TextBox 2"/>
+          <p:cNvSpPr txBox="1"/>
+          <p:nvPr/>
+        </p:nvSpPr>
+        <p:spPr>
+          <a:xfrm>
+            <a:off x="457200" y="1463040"/>
+            <a:ext cx="8229600" cy="3657600"/>
+          </a:xfrm>
+          <a:prstGeom prst="rect">
+            <a:avLst/>
+          </a:prstGeom>
+          <a:noFill/>
+        </p:spPr>
+        <p:txBody>
+          <a:bodyPr wrap="none">
+            <a:spAutoFit/>
+          </a:bodyPr>
+          <a:lstStyle/>
+          <a:p>
+            <a:r>
+              <a:t>Speech in, a model, speech out, and the network that carries the audio.</a:t>
+            </a:r>
+          </a:p>
+          <a:p>
+            <a:r>
+              <a:t>Speech in, a model, speech out</a:t>
+            </a:r>
+          </a:p>
+          <a:p>
+            <a:r>
+              <a:t>Turn-taking and barge-in</a:t>
+            </a:r>
+          </a:p>
+          <a:p>
+            <a:r>
+              <a:t>Latency budgets you label</a:t>
+            </a:r>
+          </a:p>
+          <a:p>
+            <a:r>
+              <a:t>Telephony and WebRTC</a:t>
+            </a:r>
+          </a:p>
+          <a:p>
+            <a:r>
+              <a:t>LiveKit Agents and Pipecat</a:t>
+            </a:r>
+          </a:p>
+          <a:p>
+            <a:r>
+              <a:t>A hosted voice agent, from the xAI docs</a:t>
+            </a:r>
+          </a:p>
+          <a:p>
+            <a:r>
+              <a:t>Sources and go deeper</a:t>
+            </a:r>
+          </a:p>
+          <a:p>
+            <a:r>
+              <a:t>LiveKit Agents, Pipeline types (vendor)</a:t>
+            </a:r>
+          </a:p>
+          <a:p>
+            <a:r>
+              <a:t>last checked 2026-10</a:t>
+            </a:r>
+          </a:p>
+          <a:p>
+            <a:r>
+              <a:t>https://docs.livekit.io/agents/models/pipelines/</a:t>
+            </a:r>
+          </a:p>
+          <a:p>
+            <a:r>
+              <a:t>Pipecat open source framework (vendor)</a:t>
+            </a:r>
+          </a:p>
+          <a:p>
+            <a:r>
+              <a:t>last checked 2026-10</a:t>
+            </a:r>
+          </a:p>
+          <a:p>
+            <a:r>
+              <a:t>https://docs.pipecat.ai/overview/pipecat</a:t>
+            </a:r>
+          </a:p>
+          <a:p>
+            <a:r>
+              <a:t>Voice Overview, docs.x.ai (vendor)</a:t>
+            </a:r>
+          </a:p>
+          <a:p>
+            <a:r>
+              <a:t>The page calls them SpaceXSI Voice APIs, powered by Grok, and separates Speech to Speech, Text to Speech, and Speech to Text.</a:t>
+            </a:r>
+          </a:p>
+          <a:p>
+            <a:r>
+              <a:t>last checked 2026-10</a:t>
+            </a:r>
+          </a:p>
+          <a:p>
+            <a:r>
+              <a:t>https://docs.x.ai/developers/model-capabilities/audio/voice</a:t>
+            </a:r>
+          </a:p>
+          <a:p>
+            <a:r>
+              <a:t>LiveKit Agents, Turns overview (vendor)</a:t>
+            </a:r>
+          </a:p>
+          <a:p>
+            <a:r>
+              <a:t>last checked 2026-10</a:t>
+            </a:r>
+          </a:p>
+          <a:p>
+            <a:r>
+              <a:t>https://docs.livekit.io/agents/logic/turns/</a:t>
+            </a:r>
+          </a:p>
+          <a:p>
+            <a:r>
+              <a:t>Speech to Speech, docs.x.ai (vendor)</a:t>
+            </a:r>
+          </a:p>
+          <a:p>
+            <a:r>
+              <a:t>The page title is Speech to Speech. The body names the Grok Speech to Speech API and also calls the site SpaceXSI Docs.</a:t>
+            </a:r>
+          </a:p>
+          <a:p>
+            <a:r>
+              <a:t>last checked 2026-10</a:t>
+            </a:r>
+          </a:p>
+          <a:p>
+            <a:r>
+              <a:t>https://docs.x.ai/developers/model-capabilities/audio/speech-to-speech</a:t>
+            </a:r>
+          </a:p>
+          <a:p>
+            <a:r>
+              <a:t>Python 3 tutorial (vendor)</a:t>
+            </a:r>
+          </a:p>
+          <a:p>
+            <a:r>
+              <a:t>last checked 2026-10</a:t>
+            </a:r>
+          </a:p>
+          <a:p>
+            <a:r>
+              <a:t>https://docs.python.org/3/tutorial/</a:t>
+            </a:r>
+          </a:p>
+        </p:txBody>
+      </p:sp>
+      <p:sp>
+        <p:nvSpPr>
+          <p:cNvPr id="4" name="TextBox 3"/>
+          <p:cNvSpPr txBox="1"/>
+          <p:nvPr/>
+        </p:nvSpPr>
+        <p:spPr>
+          <a:xfrm>
+            <a:off x="457200" y="5852160"/>
+            <a:ext cx="8229600" cy="731520"/>
+          </a:xfrm>
+          <a:prstGeom prst="rect">
+            <a:avLst/>
+          </a:prstGeom>
+          <a:noFill/>
+        </p:spPr>
+        <p:txBody>
+          <a:bodyPr wrap="none">
+            <a:spAutoFit/>
+          </a:bodyPr>
+          <a:lstStyle/>
+          <a:p>
+            <a:r>
+              <a:t>Learning-only student project. Nothing sold. https://linktr.ee/cypherMonkey</a:t>
+            </a:r>
+          </a:p>
+        </p:txBody>
+      </p:sp>
+    </p:spTree>
+  </p:cSld>
+  <p:clrMapOvr>
+    <a:masterClrMapping/>
+  </p:clrMapOvr>
+</p:sld>
+</file>
+
+<file path=ppt/slides/slide11.xml><?xml version="1.0" encoding="utf-8"?>
+<p:sld xmlns:a="http://schemas.openxmlformats.org/drawingml/2006/main" xmlns:p="http://schemas.openxmlformats.org/presentationml/2006/main" xmlns:r="http://schemas.openxmlformats.org/officeDocument/2006/relationships">
+  <p:cSld>
+    <p:spTree>
+      <p:nvGrpSpPr>
+        <p:cNvPr id="1" name=""/>
+        <p:cNvGrpSpPr/>
+        <p:nvPr/>
+      </p:nvGrpSpPr>
+      <p:grpSpPr/>
+      <p:sp>
+        <p:nvSpPr>
+          <p:cNvPr id="2" name="TextBox 1"/>
+          <p:cNvSpPr txBox="1"/>
+          <p:nvPr/>
+        </p:nvSpPr>
+        <p:spPr>
+          <a:xfrm>
+            <a:off x="457200" y="365760"/>
+            <a:ext cx="8229600" cy="914400"/>
+          </a:xfrm>
+          <a:prstGeom prst="rect">
+            <a:avLst/>
+          </a:prstGeom>
+          <a:noFill/>
+        </p:spPr>
+        <p:txBody>
+          <a:bodyPr wrap="none">
+            <a:spAutoFit/>
+          </a:bodyPr>
+          <a:lstStyle/>
+          <a:p>
+            <a:r>
+              <a:rPr sz="3200">
+                <a:solidFill>
+                  <a:srgbClr val="0F172A"/>
+                </a:solidFill>
+              </a:rPr>
+              <a:t>Speech analytics and quality</a:t>
+            </a:r>
+          </a:p>
+        </p:txBody>
+      </p:sp>
+      <p:sp>
+        <p:nvSpPr>
+          <p:cNvPr id="3" name="TextBox 2"/>
+          <p:cNvSpPr txBox="1"/>
+          <p:nvPr/>
+        </p:nvSpPr>
+        <p:spPr>
+          <a:xfrm>
+            <a:off x="457200" y="1463040"/>
+            <a:ext cx="8229600" cy="3657600"/>
+          </a:xfrm>
+          <a:prstGeom prst="rect">
+            <a:avLst/>
+          </a:prstGeom>
+          <a:noFill/>
+        </p:spPr>
+        <p:txBody>
+          <a:bodyPr wrap="none">
+            <a:spAutoFit/>
+          </a:bodyPr>
+          <a:lstStyle/>
+          <a:p>
+            <a:r>
+              <a:t>Transcription, sentiment, a QA score, and redaction, with the pitfalls named.</a:t>
+            </a:r>
+          </a:p>
+          <a:p>
+            <a:r>
+              <a:t>Transcription of a recording</a:t>
+            </a:r>
+          </a:p>
+          <a:p>
+            <a:r>
+              <a:t>Sentiment is a label</a:t>
+            </a:r>
+          </a:p>
+          <a:p>
+            <a:r>
+              <a:t>A QA score needs a rubric</a:t>
+            </a:r>
+          </a:p>
+          <a:p>
+            <a:r>
+              <a:t>Redaction</a:t>
+            </a:r>
+          </a:p>
+          <a:p>
+            <a:r>
+              <a:t>Pitfalls</a:t>
+            </a:r>
+          </a:p>
+          <a:p>
+            <a:r>
+              <a:t>Sources and go deeper</a:t>
+            </a:r>
+          </a:p>
+          <a:p>
+            <a:r>
+              <a:t>Speech analytics — Wikipedia (wikipedia)</a:t>
+            </a:r>
+          </a:p>
+          <a:p>
+            <a:r>
+              <a:t>last checked 2026-10</a:t>
+            </a:r>
+          </a:p>
+          <a:p>
+            <a:r>
+              <a:t>https://en.wikipedia.org/wiki/Speech_analytics</a:t>
+            </a:r>
+          </a:p>
+          <a:p>
+            <a:r>
+              <a:t>Speech recognition — Wikipedia (wikipedia)</a:t>
+            </a:r>
+          </a:p>
+          <a:p>
+            <a:r>
+              <a:t>last checked 2026-10</a:t>
+            </a:r>
+          </a:p>
+          <a:p>
+            <a:r>
+              <a:t>https://en.wikipedia.org/wiki/Speech_recognition</a:t>
+            </a:r>
+          </a:p>
+          <a:p>
+            <a:r>
+              <a:t>Sentiment analysis — Wikipedia (wikipedia)</a:t>
+            </a:r>
+          </a:p>
+          <a:p>
+            <a:r>
+              <a:t>last checked 2026-10</a:t>
+            </a:r>
+          </a:p>
+          <a:p>
+            <a:r>
+              <a:t>https://en.wikipedia.org/wiki/Sentiment_analysis</a:t>
+            </a:r>
+          </a:p>
+          <a:p>
+            <a:r>
+              <a:t>Personal data — Wikipedia (wikipedia)</a:t>
+            </a:r>
+          </a:p>
+          <a:p>
+            <a:r>
+              <a:t>The page title is Personal data.</a:t>
+            </a:r>
+          </a:p>
+          <a:p>
+            <a:r>
+              <a:t>last checked 2026-10</a:t>
+            </a:r>
+          </a:p>
+          <a:p>
+            <a:r>
+              <a:t>https://en.wikipedia.org/wiki/Personally_identifiable_information</a:t>
+            </a:r>
+          </a:p>
+        </p:txBody>
+      </p:sp>
+      <p:sp>
+        <p:nvSpPr>
+          <p:cNvPr id="4" name="TextBox 3"/>
+          <p:cNvSpPr txBox="1"/>
+          <p:nvPr/>
+        </p:nvSpPr>
+        <p:spPr>
+          <a:xfrm>
+            <a:off x="457200" y="5852160"/>
+            <a:ext cx="8229600" cy="731520"/>
+          </a:xfrm>
+          <a:prstGeom prst="rect">
+            <a:avLst/>
+          </a:prstGeom>
+          <a:noFill/>
+        </p:spPr>
+        <p:txBody>
+          <a:bodyPr wrap="none">
+            <a:spAutoFit/>
+          </a:bodyPr>
+          <a:lstStyle/>
+          <a:p>
+            <a:r>
+              <a:t>Learning-only student project. Nothing sold. https://linktr.ee/cypherMonkey</a:t>
+            </a:r>
+          </a:p>
+        </p:txBody>
+      </p:sp>
+    </p:spTree>
+  </p:cSld>
+  <p:clrMapOvr>
+    <a:masterClrMapping/>
+  </p:clrMapOvr>
+</p:sld>
+</file>
+
+<file path=ppt/slides/slide12.xml><?xml version="1.0" encoding="utf-8"?>
+<p:sld xmlns:a="http://schemas.openxmlformats.org/drawingml/2006/main" xmlns:p="http://schemas.openxmlformats.org/presentationml/2006/main" xmlns:r="http://schemas.openxmlformats.org/officeDocument/2006/relationships">
+  <p:cSld>
+    <p:spTree>
+      <p:nvGrpSpPr>
+        <p:cNvPr id="1" name=""/>
+        <p:cNvGrpSpPr/>
+        <p:nvPr/>
+      </p:nvGrpSpPr>
+      <p:grpSpPr/>
+      <p:sp>
+        <p:nvSpPr>
+          <p:cNvPr id="2" name="TextBox 1"/>
+          <p:cNvSpPr txBox="1"/>
+          <p:nvPr/>
+        </p:nvSpPr>
+        <p:spPr>
+          <a:xfrm>
+            <a:off x="457200" y="365760"/>
+            <a:ext cx="8229600" cy="914400"/>
+          </a:xfrm>
+          <a:prstGeom prst="rect">
+            <a:avLst/>
+          </a:prstGeom>
+          <a:noFill/>
+        </p:spPr>
+        <p:txBody>
+          <a:bodyPr wrap="none">
+            <a:spAutoFit/>
+          </a:bodyPr>
+          <a:lstStyle/>
+          <a:p>
+            <a:r>
+              <a:rPr sz="3200">
+                <a:solidFill>
+                  <a:srgbClr val="0F172A"/>
+                </a:solidFill>
+              </a:rPr>
+              <a:t>AI agent safety</a:t>
+            </a:r>
+          </a:p>
+        </p:txBody>
+      </p:sp>
+      <p:sp>
+        <p:nvSpPr>
+          <p:cNvPr id="3" name="TextBox 2"/>
+          <p:cNvSpPr txBox="1"/>
+          <p:nvPr/>
+        </p:nvSpPr>
+        <p:spPr>
+          <a:xfrm>
+            <a:off x="457200" y="1463040"/>
+            <a:ext cx="8229600" cy="3657600"/>
+          </a:xfrm>
+          <a:prstGeom prst="rect">
+            <a:avLst/>
+          </a:prstGeom>
+          <a:noFill/>
+        </p:spPr>
+        <p:txBody>
+          <a:bodyPr wrap="none">
+            <a:spAutoFit/>
+          </a:bodyPr>
+          <a:lstStyle/>
+          <a:p>
+            <a:r>
+              <a:t>Handoff, guardrails, consent as education, and a test you can re-run.</a:t>
+            </a:r>
+          </a:p>
+          <a:p>
+            <a:r>
+              <a:t>Handoff to a person</a:t>
+            </a:r>
+          </a:p>
+          <a:p>
+            <a:r>
+              <a:t>Guardrails</a:t>
+            </a:r>
+          </a:p>
+          <a:p>
+            <a:r>
+              <a:t>Consent and recording, as education</a:t>
+            </a:r>
+          </a:p>
+          <a:p>
+            <a:r>
+              <a:t>Evaluation and testing</a:t>
+            </a:r>
+          </a:p>
+          <a:p>
+            <a:r>
+              <a:t>What this chapter will not claim</a:t>
+            </a:r>
+          </a:p>
+          <a:p>
+            <a:r>
+              <a:t>Sources and go deeper</a:t>
+            </a:r>
+          </a:p>
+          <a:p>
+            <a:r>
+              <a:t>Pipecat open source framework (vendor)</a:t>
+            </a:r>
+          </a:p>
+          <a:p>
+            <a:r>
+              <a:t>last checked 2026-10</a:t>
+            </a:r>
+          </a:p>
+          <a:p>
+            <a:r>
+              <a:t>https://docs.pipecat.ai/overview/pipecat</a:t>
+            </a:r>
+          </a:p>
+          <a:p>
+            <a:r>
+              <a:t>NIST AI Risk Management Framework (spec)</a:t>
+            </a:r>
+          </a:p>
+          <a:p>
+            <a:r>
+              <a:t>last checked 2026-10</a:t>
+            </a:r>
+          </a:p>
+          <a:p>
+            <a:r>
+              <a:t>https://www.nist.gov/itl/ai-risk-management-framework</a:t>
+            </a:r>
+          </a:p>
+          <a:p>
+            <a:r>
+              <a:t>Anthropic, Building effective agents (vendor)</a:t>
+            </a:r>
+          </a:p>
+          <a:p>
+            <a:r>
+              <a:t>last checked 2026-10</a:t>
+            </a:r>
+          </a:p>
+          <a:p>
+            <a:r>
+              <a:t>https://www.anthropic.com/engineering/building-effective-agents</a:t>
+            </a:r>
+          </a:p>
+          <a:p>
+            <a:r>
+              <a:t>OWASP Top 10 for Large Language Model Applications (community)</a:t>
+            </a:r>
+          </a:p>
+          <a:p>
+            <a:r>
+              <a:t>last checked 2026-10</a:t>
+            </a:r>
+          </a:p>
+          <a:p>
+            <a:r>
+              <a:t>https://owasp.org/projects/top-10-for-large-language-model-applications</a:t>
+            </a:r>
+          </a:p>
+          <a:p>
+            <a:r>
+              <a:t>Speech to Speech, docs.x.ai (vendor)</a:t>
+            </a:r>
+          </a:p>
+          <a:p>
+            <a:r>
+              <a:t>The page title is Speech to Speech. The body names the Grok Speech to Speech API and also calls the site SpaceXSI Docs.</a:t>
+            </a:r>
+          </a:p>
+          <a:p>
+            <a:r>
+              <a:t>last checked 2026-10</a:t>
+            </a:r>
+          </a:p>
+          <a:p>
+            <a:r>
+              <a:t>https://docs.x.ai/developers/model-capabilities/audio/speech-to-speech</a:t>
+            </a:r>
+          </a:p>
+          <a:p>
+            <a:r>
+              <a:t>18 U.S.C. § 2511, Cornell Law School (spec)</a:t>
+            </a:r>
+          </a:p>
+          <a:p>
+            <a:r>
+              <a:t>Educational reading of one federal section. Not legal advice, and not a survey of state law.</a:t>
+            </a:r>
+          </a:p>
+          <a:p>
+            <a:r>
+              <a:t>last checked 2026-10</a:t>
+            </a:r>
+          </a:p>
+          <a:p>
+            <a:r>
+              <a:t>https://www.law.cornell.edu/uscode/text/18/2511</a:t>
+            </a:r>
+          </a:p>
+        </p:txBody>
+      </p:sp>
+      <p:sp>
+        <p:nvSpPr>
+          <p:cNvPr id="4" name="TextBox 3"/>
+          <p:cNvSpPr txBox="1"/>
+          <p:nvPr/>
+        </p:nvSpPr>
+        <p:spPr>
+          <a:xfrm>
+            <a:off x="457200" y="5852160"/>
+            <a:ext cx="8229600" cy="731520"/>
+          </a:xfrm>
+          <a:prstGeom prst="rect">
+            <a:avLst/>
+          </a:prstGeom>
+          <a:noFill/>
+        </p:spPr>
+        <p:txBody>
+          <a:bodyPr wrap="none">
+            <a:spAutoFit/>
+          </a:bodyPr>
+          <a:lstStyle/>
+          <a:p>
+            <a:r>
+              <a:t>Learning-only student project. Nothing sold. https://linktr.ee/cypherMonkey</a:t>
+            </a:r>
+          </a:p>
+        </p:txBody>
+      </p:sp>
+    </p:spTree>
+  </p:cSld>
+  <p:clrMapOvr>
+    <a:masterClrMapping/>
+  </p:clrMapOvr>
+</p:sld>
+</file>
+
+<file path=ppt/slides/slide13.xml><?xml version="1.0" encoding="utf-8"?>
+<p:sld xmlns:a="http://schemas.openxmlformats.org/drawingml/2006/main" xmlns:p="http://schemas.openxmlformats.org/presentationml/2006/main" xmlns:r="http://schemas.openxmlformats.org/officeDocument/2006/relationships">
+  <p:cSld>
+    <p:spTree>
+      <p:nvGrpSpPr>
+        <p:cNvPr id="1" name=""/>
+        <p:cNvGrpSpPr/>
+        <p:nvPr/>
+      </p:nvGrpSpPr>
+      <p:grpSpPr/>
+      <p:sp>
+        <p:nvSpPr>
+          <p:cNvPr id="2" name="TextBox 1"/>
+          <p:cNvSpPr txBox="1"/>
+          <p:nvPr/>
+        </p:nvSpPr>
+        <p:spPr>
+          <a:xfrm>
+            <a:off x="457200" y="365760"/>
+            <a:ext cx="8229600" cy="914400"/>
+          </a:xfrm>
+          <a:prstGeom prst="rect">
+            <a:avLst/>
+          </a:prstGeom>
+          <a:noFill/>
+        </p:spPr>
+        <p:txBody>
+          <a:bodyPr wrap="none">
+            <a:spAutoFit/>
+          </a:bodyPr>
+          <a:lstStyle/>
+          <a:p>
+            <a:r>
+              <a:rPr sz="3200">
+                <a:solidFill>
+                  <a:srgbClr val="0F172A"/>
+                </a:solidFill>
+              </a:rPr>
+              <a:t>Contact-center ecosystem</a:t>
+            </a:r>
+          </a:p>
+        </p:txBody>
+      </p:sp>
+      <p:sp>
+        <p:nvSpPr>
+          <p:cNvPr id="3" name="TextBox 2"/>
+          <p:cNvSpPr txBox="1"/>
+          <p:nvPr/>
+        </p:nvSpPr>
+        <p:spPr>
+          <a:xfrm>
+            <a:off x="457200" y="1463040"/>
+            <a:ext cx="8229600" cy="3657600"/>
+          </a:xfrm>
+          <a:prstGeom prst="rect">
+            <a:avLst/>
+          </a:prstGeom>
+          <a:noFill/>
+        </p:spPr>
+        <p:txBody>
+          <a:bodyPr wrap="none">
+            <a:spAutoFit/>
+          </a:bodyPr>
+          <a:lstStyle/>
+          <a:p>
+            <a:r>
+              <a:t>A glossary, a mind map, sister systems, an integration map, bridges, and future hooks.</a:t>
+            </a:r>
+          </a:p>
+          <a:p>
+            <a:r>
+              <a:t>Words for this ecosystem</a:t>
+            </a:r>
+          </a:p>
+          <a:p>
+            <a:r>
+              <a:t>A mind map</a:t>
+            </a:r>
+          </a:p>
+          <a:p>
+            <a:r>
+              <a:t>Sister technologies</a:t>
+            </a:r>
+          </a:p>
+          <a:p>
+            <a:r>
+              <a:t>An integration map</a:t>
+            </a:r>
+          </a:p>
+          <a:p>
+            <a:r>
+              <a:t>Bridges across platforms</a:t>
+            </a:r>
+          </a:p>
+          <a:p>
+            <a:r>
+              <a:t>Future hooks</a:t>
+            </a:r>
+          </a:p>
+          <a:p>
+            <a:r>
+              <a:t>Sources and go deeper</a:t>
+            </a:r>
+          </a:p>
+          <a:p>
+            <a:r>
+              <a:t>Speech analytics — Wikipedia (wikipedia)</a:t>
+            </a:r>
+          </a:p>
+          <a:p>
+            <a:r>
+              <a:t>last checked 2026-10</a:t>
+            </a:r>
+          </a:p>
+          <a:p>
+            <a:r>
+              <a:t>https://en.wikipedia.org/wiki/Speech_analytics</a:t>
+            </a:r>
+          </a:p>
+          <a:p>
+            <a:r>
+              <a:t>Customer relationship management — Wikipedia (wikipedia)</a:t>
+            </a:r>
+          </a:p>
+          <a:p>
+            <a:r>
+              <a:t>last checked 2026-10</a:t>
+            </a:r>
+          </a:p>
+          <a:p>
+            <a:r>
+              <a:t>https://en.wikipedia.org/wiki/Customer_relationship_management</a:t>
+            </a:r>
+          </a:p>
+          <a:p>
+            <a:r>
+              <a:t>Workforce management — Wikipedia (wikipedia)</a:t>
+            </a:r>
+          </a:p>
+          <a:p>
+            <a:r>
+              <a:t>last checked 2026-10</a:t>
+            </a:r>
+          </a:p>
+          <a:p>
+            <a:r>
+              <a:t>https://en.wikipedia.org/wiki/Workforce_management</a:t>
+            </a:r>
+          </a:p>
+          <a:p>
+            <a:r>
+              <a:t>Platform as a service — Wikipedia (wikipedia)</a:t>
+            </a:r>
+          </a:p>
+          <a:p>
+            <a:r>
+              <a:t>That URL opened the Platform as a service article. The communications-platform section is on that page.</a:t>
+            </a:r>
+          </a:p>
+          <a:p>
+            <a:r>
+              <a:t>last checked 2026-10</a:t>
+            </a:r>
+          </a:p>
+          <a:p>
+            <a:r>
+              <a:t>https://en.wikipedia.org/wiki/Communications_platform_as_a_service</a:t>
+            </a:r>
+          </a:p>
+          <a:p>
+            <a:r>
+              <a:t>FCC, Multi-line telephone systems: Kari’s Law and RAY BAUM’S Act (spec)</a:t>
+            </a:r>
+          </a:p>
+          <a:p>
+            <a:r>
+              <a:t>The page says its timeline is not the full rule text. Educational reading, not legal advice.</a:t>
+            </a:r>
+          </a:p>
+          <a:p>
+            <a:r>
+              <a:t>last checked 2026-10</a:t>
+            </a:r>
+          </a:p>
+          <a:p>
+            <a:r>
+              <a:t>https://www.fcc.gov/mlts-911-requirements</a:t>
+            </a:r>
+          </a:p>
+          <a:p>
+            <a:r>
+              <a:t>NIST AI Risk Management Framework (spec)</a:t>
+            </a:r>
+          </a:p>
+          <a:p>
+            <a:r>
+              <a:t>last checked 2026-10</a:t>
+            </a:r>
+          </a:p>
+          <a:p>
+            <a:r>
+              <a:t>https://www.nist.gov/itl/ai-risk-management-framework</a:t>
+            </a:r>
+          </a:p>
+        </p:txBody>
+      </p:sp>
+      <p:sp>
+        <p:nvSpPr>
+          <p:cNvPr id="4" name="TextBox 3"/>
+          <p:cNvSpPr txBox="1"/>
+          <p:nvPr/>
+        </p:nvSpPr>
+        <p:spPr>
+          <a:xfrm>
+            <a:off x="457200" y="5852160"/>
+            <a:ext cx="8229600" cy="731520"/>
+          </a:xfrm>
+          <a:prstGeom prst="rect">
+            <a:avLst/>
+          </a:prstGeom>
+          <a:noFill/>
+        </p:spPr>
+        <p:txBody>
+          <a:bodyPr wrap="none">
+            <a:spAutoFit/>
+          </a:bodyPr>
+          <a:lstStyle/>
+          <a:p>
+            <a:r>
+              <a:t>Learning-only student project. Nothing sold. https://linktr.ee/cypherMonkey</a:t>
             </a:r>
           </a:p>
         </p:txBody>

</xml_diff>